<commit_message>
feat: reskin deck (HTML + PPTX) to the B&W serif system; intentional camera placeholders
Bring the venue deck in line with the monochrome serif brand: Fraunces + Inter,
warm black-and-white palette, no colour accent (emphasis via italic). Both the
self-contained HTML deck and the editable PowerPoint (regenerated from
build_pptx.py) now match the site.

Also replace the empty grey photo placeholders with a faint analog-camera mark
(deck slides + site print frames) so unfilled slots read as intentional, not
broken — the real-photo SWAP path is unchanged.
</commit_message>
<xml_diff>
--- a/deck/future-nostalgia-deck.pptx
+++ b/deck/future-nostalgia-deck.pptx
@@ -3089,7 +3089,7 @@
     <p:bg>
       <p:bgPr>
         <a:solidFill>
-          <a:srgbClr val="F4F1EA"/>
+          <a:srgbClr val="F7F5F0"/>
         </a:solidFill>
         <a:effectLst/>
       </p:bgPr>
@@ -3153,9 +3153,9 @@
               </a:lnSpc>
             </a:pPr>
             <a:r>
-              <a:rPr sz="975" b="1" spc="120">
-                <a:solidFill>
-                  <a:srgbClr val="2B5B5D"/>
+              <a:rPr sz="975" b="1" i="0" spc="120">
+                <a:solidFill>
+                  <a:srgbClr val="1A1714"/>
                 </a:solidFill>
                 <a:latin typeface="Inter"/>
               </a:rPr>
@@ -3192,11 +3192,11 @@
               </a:lnSpc>
             </a:pPr>
             <a:r>
-              <a:rPr sz="5550" b="1" spc="-105">
-                <a:solidFill>
-                  <a:srgbClr val="2D2D2A"/>
-                </a:solidFill>
-                <a:latin typeface="Jost"/>
+              <a:rPr sz="5550" b="1" i="0" spc="-105">
+                <a:solidFill>
+                  <a:srgbClr val="1A1714"/>
+                </a:solidFill>
+                <a:latin typeface="Fraunces"/>
               </a:rPr>
               <a:t>Photos your guests actually keep.</a:t>
             </a:r>
@@ -3231,9 +3231,9 @@
               </a:lnSpc>
             </a:pPr>
             <a:r>
-              <a:rPr sz="1500" b="0">
-                <a:solidFill>
-                  <a:srgbClr val="5A5A55"/>
+              <a:rPr sz="1500" b="0" i="0">
+                <a:solidFill>
+                  <a:srgbClr val="6E6A62"/>
                 </a:solidFill>
                 <a:latin typeface="Inter"/>
               </a:rPr>
@@ -3270,9 +3270,9 @@
               </a:lnSpc>
             </a:pPr>
             <a:r>
-              <a:rPr sz="975" b="0">
-                <a:solidFill>
-                  <a:srgbClr val="5A5A55"/>
+              <a:rPr sz="975" b="0" i="0">
+                <a:solidFill>
+                  <a:srgbClr val="6E6A62"/>
                 </a:solidFill>
                 <a:latin typeface="Inter"/>
               </a:rPr>
@@ -3296,7 +3296,7 @@
             <a:avLst/>
           </a:prstGeom>
           <a:solidFill>
-            <a:srgbClr val="D1D1CE"/>
+            <a:srgbClr val="E2DDD3"/>
           </a:solidFill>
           <a:ln>
             <a:noFill/>
@@ -3339,9 +3339,9 @@
               </a:lnSpc>
             </a:pPr>
             <a:r>
-              <a:rPr sz="975" b="0">
-                <a:solidFill>
-                  <a:srgbClr val="5A5A55"/>
+              <a:rPr sz="975" b="0" i="0">
+                <a:solidFill>
+                  <a:srgbClr val="6E6A62"/>
                 </a:solidFill>
                 <a:latin typeface="Inter"/>
               </a:rPr>
@@ -3365,11 +3365,11 @@
             <a:avLst/>
           </a:prstGeom>
           <a:solidFill>
-            <a:srgbClr val="FBF8F1"/>
+            <a:srgbClr val="FCFBF7"/>
           </a:solidFill>
           <a:ln w="9525">
             <a:solidFill>
-              <a:srgbClr val="C5C2B6"/>
+              <a:srgbClr val="D2CCBF"/>
             </a:solidFill>
           </a:ln>
           <a:effectLst/>
@@ -3397,7 +3397,7 @@
             <a:avLst/>
           </a:prstGeom>
           <a:solidFill>
-            <a:srgbClr val="CDD4CE"/>
+            <a:srgbClr val="E4DFD5"/>
           </a:solidFill>
           <a:ln>
             <a:noFill/>
@@ -3420,6 +3420,96 @@
         </p:nvSpPr>
         <p:spPr>
           <a:xfrm>
+            <a:off x="9334690" y="3678078"/>
+            <a:ext cx="875919" cy="597217"/>
+          </a:xfrm>
+          <a:prstGeom prst="rect">
+            <a:avLst/>
+          </a:prstGeom>
+          <a:noFill/>
+          <a:ln w="12382">
+            <a:solidFill>
+              <a:srgbClr val="9C978C"/>
+            </a:solidFill>
+          </a:ln>
+          <a:effectLst/>
+        </p:spPr>
+        <p:txBody>
+          <a:bodyPr rtlCol="0" anchor="ctr"/>
+          <a:lstStyle/>
+          <a:p>
+            <a:pPr algn="ctr"/>
+          </a:p>
+        </p:txBody>
+      </p:sp>
+      <p:sp>
+        <p:nvSpPr>
+          <p:cNvPr id="12" name="Oval 11"/>
+          <p:cNvSpPr/>
+          <p:nvPr/>
+        </p:nvSpPr>
+        <p:spPr>
+          <a:xfrm>
+            <a:off x="9569596" y="3803494"/>
+            <a:ext cx="406107" cy="406107"/>
+          </a:xfrm>
+          <a:prstGeom prst="ellipse">
+            <a:avLst/>
+          </a:prstGeom>
+          <a:noFill/>
+          <a:ln w="12382">
+            <a:solidFill>
+              <a:srgbClr val="9C978C"/>
+            </a:solidFill>
+          </a:ln>
+          <a:effectLst/>
+        </p:spPr>
+        <p:txBody>
+          <a:bodyPr rtlCol="0" anchor="ctr"/>
+          <a:lstStyle/>
+          <a:p>
+            <a:pPr algn="ctr"/>
+          </a:p>
+        </p:txBody>
+      </p:sp>
+      <p:sp>
+        <p:nvSpPr>
+          <p:cNvPr id="13" name="Rectangle 12"/>
+          <p:cNvSpPr/>
+          <p:nvPr/>
+        </p:nvSpPr>
+        <p:spPr>
+          <a:xfrm>
+            <a:off x="9641262" y="3588496"/>
+            <a:ext cx="262775" cy="89582"/>
+          </a:xfrm>
+          <a:prstGeom prst="rect">
+            <a:avLst/>
+          </a:prstGeom>
+          <a:noFill/>
+          <a:ln w="12382">
+            <a:solidFill>
+              <a:srgbClr val="9C978C"/>
+            </a:solidFill>
+          </a:ln>
+          <a:effectLst/>
+        </p:spPr>
+        <p:txBody>
+          <a:bodyPr rtlCol="0" anchor="ctr"/>
+          <a:lstStyle/>
+          <a:p>
+            <a:pPr algn="ctr"/>
+          </a:p>
+        </p:txBody>
+      </p:sp>
+      <p:sp>
+        <p:nvSpPr>
+          <p:cNvPr id="14" name="Rectangle 13"/>
+          <p:cNvSpPr/>
+          <p:nvPr/>
+        </p:nvSpPr>
+        <p:spPr>
+          <a:xfrm>
             <a:off x="8353424" y="4724400"/>
             <a:ext cx="1207770" cy="171450"/>
           </a:xfrm>
@@ -3427,11 +3517,11 @@
             <a:avLst/>
           </a:prstGeom>
           <a:solidFill>
-            <a:srgbClr val="F4F1EA"/>
+            <a:srgbClr val="F7F5F0"/>
           </a:solidFill>
           <a:ln w="9525">
             <a:solidFill>
-              <a:srgbClr val="2B5B5D"/>
+              <a:srgbClr val="1A1714"/>
             </a:solidFill>
           </a:ln>
           <a:effectLst/>
@@ -3446,7 +3536,7 @@
       </p:sp>
       <p:sp>
         <p:nvSpPr>
-          <p:cNvPr id="12" name="TextBox 11"/>
+          <p:cNvPr id="15" name="TextBox 14"/>
           <p:cNvSpPr txBox="1"/>
           <p:nvPr/>
         </p:nvSpPr>
@@ -3472,9 +3562,9 @@
               </a:lnSpc>
             </a:pPr>
             <a:r>
-              <a:rPr sz="750" b="1" spc="60">
-                <a:solidFill>
-                  <a:srgbClr val="2B5B5D"/>
+              <a:rPr sz="750" b="1" i="0" spc="60">
+                <a:solidFill>
+                  <a:srgbClr val="1A1714"/>
                 </a:solidFill>
                 <a:latin typeface="Inter"/>
               </a:rPr>
@@ -3485,7 +3575,7 @@
       </p:sp>
       <p:sp>
         <p:nvSpPr>
-          <p:cNvPr id="13" name="TextBox 12"/>
+          <p:cNvPr id="16" name="TextBox 15"/>
           <p:cNvSpPr txBox="1"/>
           <p:nvPr/>
         </p:nvSpPr>
@@ -3511,9 +3601,9 @@
               </a:lnSpc>
             </a:pPr>
             <a:r>
-              <a:rPr sz="900" b="0">
-                <a:solidFill>
-                  <a:srgbClr val="5A5A55"/>
+              <a:rPr sz="900" b="0" i="0">
+                <a:solidFill>
+                  <a:srgbClr val="6E6A62"/>
                 </a:solidFill>
                 <a:latin typeface="Inter"/>
               </a:rPr>
@@ -3524,7 +3614,7 @@
       </p:sp>
       <p:sp>
         <p:nvSpPr>
-          <p:cNvPr id="14" name="Oval 13"/>
+          <p:cNvPr id="17" name="Oval 16"/>
           <p:cNvSpPr/>
           <p:nvPr/>
         </p:nvSpPr>
@@ -3539,7 +3629,7 @@
           <a:noFill/>
           <a:ln w="14287">
             <a:solidFill>
-              <a:srgbClr val="2B5B5D"/>
+              <a:srgbClr val="1A1714"/>
             </a:solidFill>
           </a:ln>
           <a:effectLst/>
@@ -3554,7 +3644,7 @@
       </p:sp>
       <p:sp>
         <p:nvSpPr>
-          <p:cNvPr id="15" name="Rectangle 14"/>
+          <p:cNvPr id="18" name="Rectangle 17"/>
           <p:cNvSpPr/>
           <p:nvPr/>
         </p:nvSpPr>
@@ -3567,7 +3657,7 @@
             <a:avLst/>
           </a:prstGeom>
           <a:solidFill>
-            <a:srgbClr val="D1D1CE"/>
+            <a:srgbClr val="E2DDD3"/>
           </a:solidFill>
           <a:ln>
             <a:noFill/>
@@ -3584,7 +3674,7 @@
       </p:sp>
       <p:pic>
         <p:nvPicPr>
-          <p:cNvPr id="16" name="Picture 15" descr="wordmark-black.png"/>
+          <p:cNvPr id="19" name="Picture 18" descr="wordmark-black.png"/>
           <p:cNvPicPr>
             <a:picLocks noChangeAspect="1"/>
           </p:cNvPicPr>
@@ -3608,7 +3698,7 @@
       </p:pic>
       <p:sp>
         <p:nvSpPr>
-          <p:cNvPr id="17" name="TextBox 16"/>
+          <p:cNvPr id="20" name="TextBox 19"/>
           <p:cNvSpPr txBox="1"/>
           <p:nvPr/>
         </p:nvSpPr>
@@ -3634,20 +3724,20 @@
               </a:lnSpc>
             </a:pPr>
             <a:r>
-              <a:rPr sz="1050" b="1">
-                <a:solidFill>
-                  <a:srgbClr val="2B5B5D"/>
-                </a:solidFill>
-                <a:latin typeface="Jost"/>
+              <a:rPr sz="1050" b="1" i="0">
+                <a:solidFill>
+                  <a:srgbClr val="1A1714"/>
+                </a:solidFill>
+                <a:latin typeface="Fraunces"/>
               </a:rPr>
               <a:t>01</a:t>
             </a:r>
             <a:r>
-              <a:rPr sz="1050" b="1">
-                <a:solidFill>
-                  <a:srgbClr val="5A5A55"/>
-                </a:solidFill>
-                <a:latin typeface="Jost"/>
+              <a:rPr sz="1050" b="1" i="0">
+                <a:solidFill>
+                  <a:srgbClr val="6E6A62"/>
+                </a:solidFill>
+                <a:latin typeface="Fraunces"/>
               </a:rPr>
               <a:t> / 06</a:t>
             </a:r>
@@ -3668,7 +3758,7 @@
     <p:bg>
       <p:bgPr>
         <a:solidFill>
-          <a:srgbClr val="F4F1EA"/>
+          <a:srgbClr val="F7F5F0"/>
         </a:solidFill>
         <a:effectLst/>
       </p:bgPr>
@@ -3695,11 +3785,11 @@
             <a:avLst/>
           </a:prstGeom>
           <a:solidFill>
-            <a:srgbClr val="CDD4CE"/>
+            <a:srgbClr val="E4DFD5"/>
           </a:solidFill>
           <a:ln w="9525">
             <a:solidFill>
-              <a:srgbClr val="C5C2B6"/>
+              <a:srgbClr val="D2CCBF"/>
             </a:solidFill>
           </a:ln>
           <a:effectLst/>
@@ -3727,7 +3817,7 @@
             <a:avLst/>
           </a:prstGeom>
           <a:solidFill>
-            <a:srgbClr val="2B5B5D"/>
+            <a:srgbClr val="1A1714"/>
           </a:solidFill>
           <a:ln>
             <a:noFill/>
@@ -3757,7 +3847,7 @@
             <a:avLst/>
           </a:prstGeom>
           <a:solidFill>
-            <a:srgbClr val="2B5B5D"/>
+            <a:srgbClr val="1A1714"/>
           </a:solidFill>
           <a:ln>
             <a:noFill/>
@@ -3800,9 +3890,9 @@
               </a:lnSpc>
             </a:pPr>
             <a:r>
-              <a:rPr sz="825" b="1" spc="105">
-                <a:solidFill>
-                  <a:srgbClr val="9A988F"/>
+              <a:rPr sz="825" b="1" i="0" spc="105">
+                <a:solidFill>
+                  <a:srgbClr val="9C978C"/>
                 </a:solidFill>
                 <a:latin typeface="Inter"/>
               </a:rPr>
@@ -3839,9 +3929,9 @@
               </a:lnSpc>
             </a:pPr>
             <a:r>
-              <a:rPr sz="825" b="0">
-                <a:solidFill>
-                  <a:srgbClr val="9A988F"/>
+              <a:rPr sz="825" b="0" i="0">
+                <a:solidFill>
+                  <a:srgbClr val="9C978C"/>
                 </a:solidFill>
                 <a:latin typeface="Inter"/>
               </a:rPr>
@@ -3865,7 +3955,7 @@
             <a:avLst/>
           </a:prstGeom>
           <a:solidFill>
-            <a:srgbClr val="2B5B5D"/>
+            <a:srgbClr val="1A1714"/>
           </a:solidFill>
           <a:ln>
             <a:noFill/>
@@ -3908,9 +3998,9 @@
               </a:lnSpc>
             </a:pPr>
             <a:r>
-              <a:rPr sz="975" b="1" spc="120">
-                <a:solidFill>
-                  <a:srgbClr val="2B5B5D"/>
+              <a:rPr sz="975" b="1" i="0" spc="120">
+                <a:solidFill>
+                  <a:srgbClr val="1A1714"/>
                 </a:solidFill>
                 <a:latin typeface="Inter"/>
               </a:rPr>
@@ -3947,20 +4037,20 @@
               </a:lnSpc>
             </a:pPr>
             <a:r>
-              <a:rPr sz="4350" b="1" spc="-60">
-                <a:solidFill>
-                  <a:srgbClr val="2D2D2A"/>
-                </a:solidFill>
-                <a:latin typeface="Jost"/>
+              <a:rPr sz="4350" b="1" i="0" spc="-60">
+                <a:solidFill>
+                  <a:srgbClr val="1A1714"/>
+                </a:solidFill>
+                <a:latin typeface="Fraunces"/>
               </a:rPr>
               <a:t>We don't remember files. We remember </a:t>
             </a:r>
             <a:r>
-              <a:rPr sz="4350" b="1" spc="-60">
-                <a:solidFill>
-                  <a:srgbClr val="FF5A36"/>
-                </a:solidFill>
-                <a:latin typeface="Jost"/>
+              <a:rPr sz="4350" b="1" i="1" spc="-60">
+                <a:solidFill>
+                  <a:srgbClr val="1A1714"/>
+                </a:solidFill>
+                <a:latin typeface="Fraunces"/>
               </a:rPr>
               <a:t>objects.</a:t>
             </a:r>
@@ -3995,9 +4085,9 @@
               </a:lnSpc>
             </a:pPr>
             <a:r>
-              <a:rPr sz="1350" b="0">
-                <a:solidFill>
-                  <a:srgbClr val="5A5A55"/>
+              <a:rPr sz="1350" b="0" i="0">
+                <a:solidFill>
+                  <a:srgbClr val="6E6A62"/>
                 </a:solidFill>
                 <a:latin typeface="Inter"/>
               </a:rPr>
@@ -4021,7 +4111,7 @@
             <a:avLst/>
           </a:prstGeom>
           <a:solidFill>
-            <a:srgbClr val="D1D1CE"/>
+            <a:srgbClr val="E2DDD3"/>
           </a:solidFill>
           <a:ln>
             <a:noFill/>
@@ -4088,20 +4178,20 @@
               </a:lnSpc>
             </a:pPr>
             <a:r>
-              <a:rPr sz="1050" b="1">
-                <a:solidFill>
-                  <a:srgbClr val="2B5B5D"/>
-                </a:solidFill>
-                <a:latin typeface="Jost"/>
+              <a:rPr sz="1050" b="1" i="0">
+                <a:solidFill>
+                  <a:srgbClr val="1A1714"/>
+                </a:solidFill>
+                <a:latin typeface="Fraunces"/>
               </a:rPr>
               <a:t>02</a:t>
             </a:r>
             <a:r>
-              <a:rPr sz="1050" b="1">
-                <a:solidFill>
-                  <a:srgbClr val="5A5A55"/>
-                </a:solidFill>
-                <a:latin typeface="Jost"/>
+              <a:rPr sz="1050" b="1" i="0">
+                <a:solidFill>
+                  <a:srgbClr val="6E6A62"/>
+                </a:solidFill>
+                <a:latin typeface="Fraunces"/>
               </a:rPr>
               <a:t> / 06</a:t>
             </a:r>
@@ -4122,7 +4212,7 @@
     <p:bg>
       <p:bgPr>
         <a:solidFill>
-          <a:srgbClr val="F4F1EA"/>
+          <a:srgbClr val="F7F5F0"/>
         </a:solidFill>
         <a:effectLst/>
       </p:bgPr>
@@ -4149,7 +4239,7 @@
             <a:avLst/>
           </a:prstGeom>
           <a:solidFill>
-            <a:srgbClr val="2B5B5D"/>
+            <a:srgbClr val="1A1714"/>
           </a:solidFill>
           <a:ln>
             <a:noFill/>
@@ -4192,9 +4282,9 @@
               </a:lnSpc>
             </a:pPr>
             <a:r>
-              <a:rPr sz="975" b="1" spc="120">
-                <a:solidFill>
-                  <a:srgbClr val="2B5B5D"/>
+              <a:rPr sz="975" b="1" i="0" spc="120">
+                <a:solidFill>
+                  <a:srgbClr val="1A1714"/>
                 </a:solidFill>
                 <a:latin typeface="Inter"/>
               </a:rPr>
@@ -4231,11 +4321,11 @@
               </a:lnSpc>
             </a:pPr>
             <a:r>
-              <a:rPr sz="3450" b="1" spc="-52">
-                <a:solidFill>
-                  <a:srgbClr val="2D2D2A"/>
-                </a:solidFill>
-                <a:latin typeface="Jost"/>
+              <a:rPr sz="3450" b="1" i="0" spc="-52">
+                <a:solidFill>
+                  <a:srgbClr val="1A1714"/>
+                </a:solidFill>
+                <a:latin typeface="Fraunces"/>
               </a:rPr>
               <a:t>I run the whole booth.</a:t>
             </a:r>
@@ -4259,7 +4349,7 @@
           <a:noFill/>
           <a:ln w="14287">
             <a:solidFill>
-              <a:srgbClr val="C5C2B6"/>
+              <a:srgbClr val="D2CCBF"/>
             </a:solidFill>
           </a:ln>
           <a:effectLst/>
@@ -4289,7 +4379,7 @@
           <a:noFill/>
           <a:ln w="14287">
             <a:solidFill>
-              <a:srgbClr val="C5C2B6"/>
+              <a:srgbClr val="D2CCBF"/>
             </a:solidFill>
           </a:ln>
           <a:effectLst/>
@@ -4319,7 +4409,7 @@
           <a:noFill/>
           <a:ln w="14287">
             <a:solidFill>
-              <a:srgbClr val="C5C2B6"/>
+              <a:srgbClr val="D2CCBF"/>
             </a:solidFill>
           </a:ln>
           <a:effectLst/>
@@ -4349,7 +4439,7 @@
           <a:noFill/>
           <a:ln w="14287">
             <a:solidFill>
-              <a:srgbClr val="C5C2B6"/>
+              <a:srgbClr val="D2CCBF"/>
             </a:solidFill>
           </a:ln>
           <a:effectLst/>
@@ -4378,7 +4468,7 @@
           </a:prstGeom>
           <a:ln w="14287">
             <a:solidFill>
-              <a:srgbClr val="9A988F"/>
+              <a:srgbClr val="9C978C"/>
             </a:solidFill>
             <a:tailEnd type="triangle" w="med" len="med"/>
           </a:ln>
@@ -4401,7 +4491,7 @@
           </a:prstGeom>
           <a:ln w="14287">
             <a:solidFill>
-              <a:srgbClr val="9A988F"/>
+              <a:srgbClr val="9C978C"/>
             </a:solidFill>
             <a:tailEnd type="triangle" w="med" len="med"/>
           </a:ln>
@@ -4424,7 +4514,7 @@
           </a:prstGeom>
           <a:ln w="14287">
             <a:solidFill>
-              <a:srgbClr val="9A988F"/>
+              <a:srgbClr val="9C978C"/>
             </a:solidFill>
             <a:tailEnd type="triangle" w="med" len="med"/>
           </a:ln>
@@ -4446,7 +4536,7 @@
             <a:avLst/>
           </a:prstGeom>
           <a:solidFill>
-            <a:srgbClr val="2B5B5D"/>
+            <a:srgbClr val="1A1714"/>
           </a:solidFill>
           <a:ln>
             <a:noFill/>
@@ -4476,7 +4566,7 @@
             <a:avLst/>
           </a:prstGeom>
           <a:solidFill>
-            <a:srgbClr val="2B5B5D"/>
+            <a:srgbClr val="1A1714"/>
           </a:solidFill>
           <a:ln>
             <a:noFill/>
@@ -4508,7 +4598,7 @@
           <a:noFill/>
           <a:ln w="23812">
             <a:solidFill>
-              <a:srgbClr val="2B5B5D"/>
+              <a:srgbClr val="1A1714"/>
             </a:solidFill>
           </a:ln>
           <a:effectLst/>
@@ -4538,7 +4628,7 @@
           <a:noFill/>
           <a:ln w="23812">
             <a:solidFill>
-              <a:srgbClr val="2B5B5D"/>
+              <a:srgbClr val="1A1714"/>
             </a:solidFill>
           </a:ln>
           <a:effectLst/>
@@ -4568,7 +4658,7 @@
           <a:noFill/>
           <a:ln w="23812">
             <a:solidFill>
-              <a:srgbClr val="2B5B5D"/>
+              <a:srgbClr val="1A1714"/>
             </a:solidFill>
           </a:ln>
           <a:effectLst/>
@@ -4598,7 +4688,7 @@
           <a:noFill/>
           <a:ln w="23812">
             <a:solidFill>
-              <a:srgbClr val="2B5B5D"/>
+              <a:srgbClr val="1A1714"/>
             </a:solidFill>
           </a:ln>
           <a:effectLst/>
@@ -4628,7 +4718,7 @@
           <a:noFill/>
           <a:ln w="23812">
             <a:solidFill>
-              <a:srgbClr val="2B5B5D"/>
+              <a:srgbClr val="1A1714"/>
             </a:solidFill>
           </a:ln>
           <a:effectLst/>
@@ -4658,7 +4748,7 @@
           <a:noFill/>
           <a:ln w="23812">
             <a:solidFill>
-              <a:srgbClr val="FF5A36"/>
+              <a:srgbClr val="1A1714"/>
             </a:solidFill>
           </a:ln>
           <a:effectLst/>
@@ -4699,9 +4789,9 @@
               </a:lnSpc>
             </a:pPr>
             <a:r>
-              <a:rPr sz="975" b="1" spc="98">
-                <a:solidFill>
-                  <a:srgbClr val="2D2D2A"/>
+              <a:rPr sz="975" b="1" i="0" spc="98">
+                <a:solidFill>
+                  <a:srgbClr val="1A1714"/>
                 </a:solidFill>
                 <a:latin typeface="Inter"/>
               </a:rPr>
@@ -4738,9 +4828,9 @@
               </a:lnSpc>
             </a:pPr>
             <a:r>
-              <a:rPr sz="937" b="0">
-                <a:solidFill>
-                  <a:srgbClr val="5A5A55"/>
+              <a:rPr sz="937" b="0" i="0">
+                <a:solidFill>
+                  <a:srgbClr val="6E6A62"/>
                 </a:solidFill>
                 <a:latin typeface="Inter"/>
               </a:rPr>
@@ -4777,9 +4867,9 @@
               </a:lnSpc>
             </a:pPr>
             <a:r>
-              <a:rPr sz="975" b="1" spc="98">
-                <a:solidFill>
-                  <a:srgbClr val="2D2D2A"/>
+              <a:rPr sz="975" b="1" i="0" spc="98">
+                <a:solidFill>
+                  <a:srgbClr val="1A1714"/>
                 </a:solidFill>
                 <a:latin typeface="Inter"/>
               </a:rPr>
@@ -4816,9 +4906,9 @@
               </a:lnSpc>
             </a:pPr>
             <a:r>
-              <a:rPr sz="937" b="0">
-                <a:solidFill>
-                  <a:srgbClr val="5A5A55"/>
+              <a:rPr sz="937" b="0" i="0">
+                <a:solidFill>
+                  <a:srgbClr val="6E6A62"/>
                 </a:solidFill>
                 <a:latin typeface="Inter"/>
               </a:rPr>
@@ -4855,9 +4945,9 @@
               </a:lnSpc>
             </a:pPr>
             <a:r>
-              <a:rPr sz="975" b="1" spc="98">
-                <a:solidFill>
-                  <a:srgbClr val="2D2D2A"/>
+              <a:rPr sz="975" b="1" i="0" spc="98">
+                <a:solidFill>
+                  <a:srgbClr val="1A1714"/>
                 </a:solidFill>
                 <a:latin typeface="Inter"/>
               </a:rPr>
@@ -4894,9 +4984,9 @@
               </a:lnSpc>
             </a:pPr>
             <a:r>
-              <a:rPr sz="937" b="0">
-                <a:solidFill>
-                  <a:srgbClr val="5A5A55"/>
+              <a:rPr sz="937" b="0" i="0">
+                <a:solidFill>
+                  <a:srgbClr val="6E6A62"/>
                 </a:solidFill>
                 <a:latin typeface="Inter"/>
               </a:rPr>
@@ -4933,9 +5023,9 @@
               </a:lnSpc>
             </a:pPr>
             <a:r>
-              <a:rPr sz="975" b="1" spc="98">
-                <a:solidFill>
-                  <a:srgbClr val="2D2D2A"/>
+              <a:rPr sz="975" b="1" i="0" spc="98">
+                <a:solidFill>
+                  <a:srgbClr val="1A1714"/>
                 </a:solidFill>
                 <a:latin typeface="Inter"/>
               </a:rPr>
@@ -4972,9 +5062,9 @@
               </a:lnSpc>
             </a:pPr>
             <a:r>
-              <a:rPr sz="937" b="0">
-                <a:solidFill>
-                  <a:srgbClr val="5A5A55"/>
+              <a:rPr sz="937" b="0" i="0">
+                <a:solidFill>
+                  <a:srgbClr val="6E6A62"/>
                 </a:solidFill>
                 <a:latin typeface="Inter"/>
               </a:rPr>
@@ -5011,9 +5101,9 @@
               </a:lnSpc>
             </a:pPr>
             <a:r>
-              <a:rPr sz="975" b="0">
-                <a:solidFill>
-                  <a:srgbClr val="5A5A55"/>
+              <a:rPr sz="975" b="0" i="0">
+                <a:solidFill>
+                  <a:srgbClr val="6E6A62"/>
                 </a:solidFill>
                 <a:latin typeface="Inter"/>
               </a:rPr>
@@ -5050,9 +5140,9 @@
               </a:lnSpc>
             </a:pPr>
             <a:r>
-              <a:rPr sz="1350" b="0">
-                <a:solidFill>
-                  <a:srgbClr val="5A5A55"/>
+              <a:rPr sz="1350" b="0" i="0">
+                <a:solidFill>
+                  <a:srgbClr val="6E6A62"/>
                 </a:solidFill>
                 <a:latin typeface="Inter"/>
               </a:rPr>
@@ -5076,7 +5166,7 @@
             <a:avLst/>
           </a:prstGeom>
           <a:solidFill>
-            <a:srgbClr val="D1D1CE"/>
+            <a:srgbClr val="E2DDD3"/>
           </a:solidFill>
           <a:ln>
             <a:noFill/>
@@ -5143,20 +5233,20 @@
               </a:lnSpc>
             </a:pPr>
             <a:r>
-              <a:rPr sz="1050" b="1">
-                <a:solidFill>
-                  <a:srgbClr val="2B5B5D"/>
-                </a:solidFill>
-                <a:latin typeface="Jost"/>
+              <a:rPr sz="1050" b="1" i="0">
+                <a:solidFill>
+                  <a:srgbClr val="1A1714"/>
+                </a:solidFill>
+                <a:latin typeface="Fraunces"/>
               </a:rPr>
               <a:t>03</a:t>
             </a:r>
             <a:r>
-              <a:rPr sz="1050" b="1">
-                <a:solidFill>
-                  <a:srgbClr val="5A5A55"/>
-                </a:solidFill>
-                <a:latin typeface="Jost"/>
+              <a:rPr sz="1050" b="1" i="0">
+                <a:solidFill>
+                  <a:srgbClr val="6E6A62"/>
+                </a:solidFill>
+                <a:latin typeface="Fraunces"/>
               </a:rPr>
               <a:t> / 06</a:t>
             </a:r>
@@ -5177,7 +5267,7 @@
     <p:bg>
       <p:bgPr>
         <a:solidFill>
-          <a:srgbClr val="F4F1EA"/>
+          <a:srgbClr val="F7F5F0"/>
         </a:solidFill>
         <a:effectLst/>
       </p:bgPr>
@@ -5204,7 +5294,7 @@
             <a:avLst/>
           </a:prstGeom>
           <a:solidFill>
-            <a:srgbClr val="2B5B5D"/>
+            <a:srgbClr val="1A1714"/>
           </a:solidFill>
           <a:ln>
             <a:noFill/>
@@ -5247,9 +5337,9 @@
               </a:lnSpc>
             </a:pPr>
             <a:r>
-              <a:rPr sz="975" b="1" spc="120">
-                <a:solidFill>
-                  <a:srgbClr val="2B5B5D"/>
+              <a:rPr sz="975" b="1" i="0" spc="120">
+                <a:solidFill>
+                  <a:srgbClr val="1A1714"/>
                 </a:solidFill>
                 <a:latin typeface="Inter"/>
               </a:rPr>
@@ -5286,11 +5376,11 @@
               </a:lnSpc>
             </a:pPr>
             <a:r>
-              <a:rPr sz="6900" b="1" spc="-105">
-                <a:solidFill>
-                  <a:srgbClr val="2D2D2A"/>
-                </a:solidFill>
-                <a:latin typeface="Jost"/>
+              <a:rPr sz="6900" b="1" i="0" spc="-105">
+                <a:solidFill>
+                  <a:srgbClr val="1A1714"/>
+                </a:solidFill>
+                <a:latin typeface="Fraunces"/>
               </a:rPr>
               <a:t>Nothing.</a:t>
             </a:r>
@@ -5325,9 +5415,9 @@
               </a:lnSpc>
             </a:pPr>
             <a:r>
-              <a:rPr sz="1425" b="0">
-                <a:solidFill>
-                  <a:srgbClr val="5A5A55"/>
+              <a:rPr sz="1425" b="0" i="0">
+                <a:solidFill>
+                  <a:srgbClr val="6E6A62"/>
                 </a:solidFill>
                 <a:latin typeface="Inter"/>
               </a:rPr>
@@ -5351,7 +5441,7 @@
             <a:avLst/>
           </a:prstGeom>
           <a:solidFill>
-            <a:srgbClr val="D1D1CE"/>
+            <a:srgbClr val="E2DDD3"/>
           </a:solidFill>
           <a:ln>
             <a:noFill/>
@@ -5381,7 +5471,7 @@
             <a:avLst/>
           </a:prstGeom>
           <a:solidFill>
-            <a:srgbClr val="2B5B5D"/>
+            <a:srgbClr val="1A1714"/>
           </a:solidFill>
           <a:ln>
             <a:noFill/>
@@ -5424,9 +5514,9 @@
               </a:lnSpc>
             </a:pPr>
             <a:r>
-              <a:rPr sz="1875" b="1" spc="-22">
-                <a:solidFill>
-                  <a:srgbClr val="2D2D2A"/>
+              <a:rPr sz="1875" b="1" i="0" spc="-22">
+                <a:solidFill>
+                  <a:srgbClr val="1A1714"/>
                 </a:solidFill>
                 <a:latin typeface="Inter"/>
               </a:rPr>
@@ -5463,9 +5553,9 @@
               </a:lnSpc>
             </a:pPr>
             <a:r>
-              <a:rPr sz="1200" b="0">
-                <a:solidFill>
-                  <a:srgbClr val="5A5A55"/>
+              <a:rPr sz="1200" b="0" i="0">
+                <a:solidFill>
+                  <a:srgbClr val="6E6A62"/>
                 </a:solidFill>
                 <a:latin typeface="Inter"/>
               </a:rPr>
@@ -5489,7 +5579,7 @@
             <a:avLst/>
           </a:prstGeom>
           <a:solidFill>
-            <a:srgbClr val="FF5A36"/>
+            <a:srgbClr val="1A1714"/>
           </a:solidFill>
           <a:ln>
             <a:noFill/>
@@ -5532,9 +5622,9 @@
               </a:lnSpc>
             </a:pPr>
             <a:r>
-              <a:rPr sz="1875" b="1" spc="-22">
-                <a:solidFill>
-                  <a:srgbClr val="2D2D2A"/>
+              <a:rPr sz="1875" b="1" i="0" spc="-22">
+                <a:solidFill>
+                  <a:srgbClr val="1A1714"/>
                 </a:solidFill>
                 <a:latin typeface="Inter"/>
               </a:rPr>
@@ -5571,9 +5661,9 @@
               </a:lnSpc>
             </a:pPr>
             <a:r>
-              <a:rPr sz="1200" b="0">
-                <a:solidFill>
-                  <a:srgbClr val="5A5A55"/>
+              <a:rPr sz="1200" b="0" i="0">
+                <a:solidFill>
+                  <a:srgbClr val="6E6A62"/>
                 </a:solidFill>
                 <a:latin typeface="Inter"/>
               </a:rPr>
@@ -5610,9 +5700,9 @@
               </a:lnSpc>
             </a:pPr>
             <a:r>
-              <a:rPr sz="1050" b="0">
-                <a:solidFill>
-                  <a:srgbClr val="5A5A55"/>
+              <a:rPr sz="1050" b="0" i="0">
+                <a:solidFill>
+                  <a:srgbClr val="6E6A62"/>
                 </a:solidFill>
                 <a:latin typeface="Inter"/>
               </a:rPr>
@@ -5636,7 +5726,7 @@
             <a:avLst/>
           </a:prstGeom>
           <a:solidFill>
-            <a:srgbClr val="D1D1CE"/>
+            <a:srgbClr val="E2DDD3"/>
           </a:solidFill>
           <a:ln>
             <a:noFill/>
@@ -5703,20 +5793,20 @@
               </a:lnSpc>
             </a:pPr>
             <a:r>
-              <a:rPr sz="1050" b="1">
-                <a:solidFill>
-                  <a:srgbClr val="2B5B5D"/>
-                </a:solidFill>
-                <a:latin typeface="Jost"/>
+              <a:rPr sz="1050" b="1" i="0">
+                <a:solidFill>
+                  <a:srgbClr val="1A1714"/>
+                </a:solidFill>
+                <a:latin typeface="Fraunces"/>
               </a:rPr>
               <a:t>04</a:t>
             </a:r>
             <a:r>
-              <a:rPr sz="1050" b="1">
-                <a:solidFill>
-                  <a:srgbClr val="5A5A55"/>
-                </a:solidFill>
-                <a:latin typeface="Jost"/>
+              <a:rPr sz="1050" b="1" i="0">
+                <a:solidFill>
+                  <a:srgbClr val="6E6A62"/>
+                </a:solidFill>
+                <a:latin typeface="Fraunces"/>
               </a:rPr>
               <a:t> / 06</a:t>
             </a:r>
@@ -5737,7 +5827,7 @@
     <p:bg>
       <p:bgPr>
         <a:solidFill>
-          <a:srgbClr val="F4F1EA"/>
+          <a:srgbClr val="F7F5F0"/>
         </a:solidFill>
         <a:effectLst/>
       </p:bgPr>
@@ -5764,7 +5854,7 @@
             <a:avLst/>
           </a:prstGeom>
           <a:solidFill>
-            <a:srgbClr val="2B5B5D"/>
+            <a:srgbClr val="1A1714"/>
           </a:solidFill>
           <a:ln>
             <a:noFill/>
@@ -5807,9 +5897,9 @@
               </a:lnSpc>
             </a:pPr>
             <a:r>
-              <a:rPr sz="975" b="1" spc="120">
-                <a:solidFill>
-                  <a:srgbClr val="2B5B5D"/>
+              <a:rPr sz="975" b="1" i="0" spc="120">
+                <a:solidFill>
+                  <a:srgbClr val="1A1714"/>
                 </a:solidFill>
                 <a:latin typeface="Inter"/>
               </a:rPr>
@@ -5846,11 +5936,11 @@
               </a:lnSpc>
             </a:pPr>
             <a:r>
-              <a:rPr sz="3450" b="1" spc="-52">
-                <a:solidFill>
-                  <a:srgbClr val="2D2D2A"/>
-                </a:solidFill>
-                <a:latin typeface="Jost"/>
+              <a:rPr sz="3450" b="1" i="0" spc="-52">
+                <a:solidFill>
+                  <a:srgbClr val="1A1714"/>
+                </a:solidFill>
+                <a:latin typeface="Fraunces"/>
               </a:rPr>
               <a:t>A real print. Your event on the border.</a:t>
             </a:r>
@@ -5872,11 +5962,11 @@
             <a:avLst/>
           </a:prstGeom>
           <a:solidFill>
-            <a:srgbClr val="FBF8F1"/>
+            <a:srgbClr val="FCFBF7"/>
           </a:solidFill>
           <a:ln w="9525">
             <a:solidFill>
-              <a:srgbClr val="C5C2B6"/>
+              <a:srgbClr val="D2CCBF"/>
             </a:solidFill>
           </a:ln>
           <a:effectLst/>
@@ -5904,7 +5994,7 @@
             <a:avLst/>
           </a:prstGeom>
           <a:solidFill>
-            <a:srgbClr val="CDD4CE"/>
+            <a:srgbClr val="E4DFD5"/>
           </a:solidFill>
           <a:ln>
             <a:noFill/>
@@ -5927,6 +6017,96 @@
         </p:nvSpPr>
         <p:spPr>
           <a:xfrm>
+            <a:off x="1720469" y="3608705"/>
+            <a:ext cx="692912" cy="472440"/>
+          </a:xfrm>
+          <a:prstGeom prst="rect">
+            <a:avLst/>
+          </a:prstGeom>
+          <a:noFill/>
+          <a:ln w="12382">
+            <a:solidFill>
+              <a:srgbClr val="9C978C"/>
+            </a:solidFill>
+          </a:ln>
+          <a:effectLst/>
+        </p:spPr>
+        <p:txBody>
+          <a:bodyPr rtlCol="0" anchor="ctr"/>
+          <a:lstStyle/>
+          <a:p>
+            <a:pPr algn="ctr"/>
+          </a:p>
+        </p:txBody>
+      </p:sp>
+      <p:sp>
+        <p:nvSpPr>
+          <p:cNvPr id="8" name="Oval 7"/>
+          <p:cNvSpPr/>
+          <p:nvPr/>
+        </p:nvSpPr>
+        <p:spPr>
+          <a:xfrm>
+            <a:off x="1906295" y="3707917"/>
+            <a:ext cx="321259" cy="321259"/>
+          </a:xfrm>
+          <a:prstGeom prst="ellipse">
+            <a:avLst/>
+          </a:prstGeom>
+          <a:noFill/>
+          <a:ln w="12382">
+            <a:solidFill>
+              <a:srgbClr val="9C978C"/>
+            </a:solidFill>
+          </a:ln>
+          <a:effectLst/>
+        </p:spPr>
+        <p:txBody>
+          <a:bodyPr rtlCol="0" anchor="ctr"/>
+          <a:lstStyle/>
+          <a:p>
+            <a:pPr algn="ctr"/>
+          </a:p>
+        </p:txBody>
+      </p:sp>
+      <p:sp>
+        <p:nvSpPr>
+          <p:cNvPr id="9" name="Rectangle 8"/>
+          <p:cNvSpPr/>
+          <p:nvPr/>
+        </p:nvSpPr>
+        <p:spPr>
+          <a:xfrm>
+            <a:off x="1962988" y="3537839"/>
+            <a:ext cx="207873" cy="70866"/>
+          </a:xfrm>
+          <a:prstGeom prst="rect">
+            <a:avLst/>
+          </a:prstGeom>
+          <a:noFill/>
+          <a:ln w="12382">
+            <a:solidFill>
+              <a:srgbClr val="9C978C"/>
+            </a:solidFill>
+          </a:ln>
+          <a:effectLst/>
+        </p:spPr>
+        <p:txBody>
+          <a:bodyPr rtlCol="0" anchor="ctr"/>
+          <a:lstStyle/>
+          <a:p>
+            <a:pPr algn="ctr"/>
+          </a:p>
+        </p:txBody>
+      </p:sp>
+      <p:sp>
+        <p:nvSpPr>
+          <p:cNvPr id="10" name="Rectangle 9"/>
+          <p:cNvSpPr/>
+          <p:nvPr/>
+        </p:nvSpPr>
+        <p:spPr>
+          <a:xfrm>
             <a:off x="962024" y="4384675"/>
             <a:ext cx="819150" cy="171450"/>
           </a:xfrm>
@@ -5934,11 +6114,11 @@
             <a:avLst/>
           </a:prstGeom>
           <a:solidFill>
-            <a:srgbClr val="F4F1EA"/>
+            <a:srgbClr val="F7F5F0"/>
           </a:solidFill>
           <a:ln w="9525">
             <a:solidFill>
-              <a:srgbClr val="2B5B5D"/>
+              <a:srgbClr val="1A1714"/>
             </a:solidFill>
           </a:ln>
           <a:effectLst/>
@@ -5953,7 +6133,7 @@
       </p:sp>
       <p:sp>
         <p:nvSpPr>
-          <p:cNvPr id="8" name="TextBox 7"/>
+          <p:cNvPr id="11" name="TextBox 10"/>
           <p:cNvSpPr txBox="1"/>
           <p:nvPr/>
         </p:nvSpPr>
@@ -5979,9 +6159,9 @@
               </a:lnSpc>
             </a:pPr>
             <a:r>
-              <a:rPr sz="750" b="1" spc="60">
-                <a:solidFill>
-                  <a:srgbClr val="2B5B5D"/>
+              <a:rPr sz="750" b="1" i="0" spc="60">
+                <a:solidFill>
+                  <a:srgbClr val="1A1714"/>
                 </a:solidFill>
                 <a:latin typeface="Inter"/>
               </a:rPr>
@@ -5992,7 +6172,7 @@
       </p:sp>
       <p:sp>
         <p:nvSpPr>
-          <p:cNvPr id="9" name="TextBox 8"/>
+          <p:cNvPr id="12" name="TextBox 11"/>
           <p:cNvSpPr txBox="1"/>
           <p:nvPr/>
         </p:nvSpPr>
@@ -6018,9 +6198,9 @@
               </a:lnSpc>
             </a:pPr>
             <a:r>
-              <a:rPr sz="900" b="0">
-                <a:solidFill>
-                  <a:srgbClr val="5A5A55"/>
+              <a:rPr sz="900" b="0" i="0">
+                <a:solidFill>
+                  <a:srgbClr val="6E6A62"/>
                 </a:solidFill>
                 <a:latin typeface="Inter"/>
               </a:rPr>
@@ -6031,7 +6211,7 @@
       </p:sp>
       <p:sp>
         <p:nvSpPr>
-          <p:cNvPr id="10" name="Oval 9"/>
+          <p:cNvPr id="13" name="Oval 12"/>
           <p:cNvSpPr/>
           <p:nvPr/>
         </p:nvSpPr>
@@ -6046,7 +6226,7 @@
           <a:noFill/>
           <a:ln w="14287">
             <a:solidFill>
-              <a:srgbClr val="2B5B5D"/>
+              <a:srgbClr val="1A1714"/>
             </a:solidFill>
           </a:ln>
           <a:effectLst/>
@@ -6061,7 +6241,7 @@
       </p:sp>
       <p:sp>
         <p:nvSpPr>
-          <p:cNvPr id="11" name="Rectangle 10"/>
+          <p:cNvPr id="14" name="Rectangle 13"/>
           <p:cNvSpPr/>
           <p:nvPr/>
         </p:nvSpPr>
@@ -6074,11 +6254,11 @@
             <a:avLst/>
           </a:prstGeom>
           <a:solidFill>
-            <a:srgbClr val="FBF8F1"/>
+            <a:srgbClr val="FCFBF7"/>
           </a:solidFill>
           <a:ln w="9525">
             <a:solidFill>
-              <a:srgbClr val="C5C2B6"/>
+              <a:srgbClr val="D2CCBF"/>
             </a:solidFill>
           </a:ln>
           <a:effectLst/>
@@ -6093,7 +6273,7 @@
       </p:sp>
       <p:sp>
         <p:nvSpPr>
-          <p:cNvPr id="12" name="Rectangle 11"/>
+          <p:cNvPr id="15" name="Rectangle 14"/>
           <p:cNvSpPr/>
           <p:nvPr/>
         </p:nvSpPr>
@@ -6106,7 +6286,7 @@
             <a:avLst/>
           </a:prstGeom>
           <a:solidFill>
-            <a:srgbClr val="CDD4CE"/>
+            <a:srgbClr val="E4DFD5"/>
           </a:solidFill>
           <a:ln>
             <a:noFill/>
@@ -6123,7 +6303,97 @@
       </p:sp>
       <p:sp>
         <p:nvSpPr>
-          <p:cNvPr id="13" name="TextBox 12"/>
+          <p:cNvPr id="16" name="Rectangle 15"/>
+          <p:cNvSpPr/>
+          <p:nvPr/>
+        </p:nvSpPr>
+        <p:spPr>
+          <a:xfrm>
+            <a:off x="4406519" y="3608705"/>
+            <a:ext cx="692912" cy="472440"/>
+          </a:xfrm>
+          <a:prstGeom prst="rect">
+            <a:avLst/>
+          </a:prstGeom>
+          <a:noFill/>
+          <a:ln w="12382">
+            <a:solidFill>
+              <a:srgbClr val="9C978C"/>
+            </a:solidFill>
+          </a:ln>
+          <a:effectLst/>
+        </p:spPr>
+        <p:txBody>
+          <a:bodyPr rtlCol="0" anchor="ctr"/>
+          <a:lstStyle/>
+          <a:p>
+            <a:pPr algn="ctr"/>
+          </a:p>
+        </p:txBody>
+      </p:sp>
+      <p:sp>
+        <p:nvSpPr>
+          <p:cNvPr id="17" name="Oval 16"/>
+          <p:cNvSpPr/>
+          <p:nvPr/>
+        </p:nvSpPr>
+        <p:spPr>
+          <a:xfrm>
+            <a:off x="4592345" y="3707917"/>
+            <a:ext cx="321259" cy="321259"/>
+          </a:xfrm>
+          <a:prstGeom prst="ellipse">
+            <a:avLst/>
+          </a:prstGeom>
+          <a:noFill/>
+          <a:ln w="12382">
+            <a:solidFill>
+              <a:srgbClr val="9C978C"/>
+            </a:solidFill>
+          </a:ln>
+          <a:effectLst/>
+        </p:spPr>
+        <p:txBody>
+          <a:bodyPr rtlCol="0" anchor="ctr"/>
+          <a:lstStyle/>
+          <a:p>
+            <a:pPr algn="ctr"/>
+          </a:p>
+        </p:txBody>
+      </p:sp>
+      <p:sp>
+        <p:nvSpPr>
+          <p:cNvPr id="18" name="Rectangle 17"/>
+          <p:cNvSpPr/>
+          <p:nvPr/>
+        </p:nvSpPr>
+        <p:spPr>
+          <a:xfrm>
+            <a:off x="4649038" y="3537839"/>
+            <a:ext cx="207873" cy="70866"/>
+          </a:xfrm>
+          <a:prstGeom prst="rect">
+            <a:avLst/>
+          </a:prstGeom>
+          <a:noFill/>
+          <a:ln w="12382">
+            <a:solidFill>
+              <a:srgbClr val="9C978C"/>
+            </a:solidFill>
+          </a:ln>
+          <a:effectLst/>
+        </p:spPr>
+        <p:txBody>
+          <a:bodyPr rtlCol="0" anchor="ctr"/>
+          <a:lstStyle/>
+          <a:p>
+            <a:pPr algn="ctr"/>
+          </a:p>
+        </p:txBody>
+      </p:sp>
+      <p:sp>
+        <p:nvSpPr>
+          <p:cNvPr id="19" name="TextBox 18"/>
           <p:cNvSpPr txBox="1"/>
           <p:nvPr/>
         </p:nvSpPr>
@@ -6149,9 +6419,9 @@
               </a:lnSpc>
             </a:pPr>
             <a:r>
-              <a:rPr sz="900" b="0">
-                <a:solidFill>
-                  <a:srgbClr val="5A5A55"/>
+              <a:rPr sz="900" b="0" i="0">
+                <a:solidFill>
+                  <a:srgbClr val="6E6A62"/>
                 </a:solidFill>
                 <a:latin typeface="Inter"/>
               </a:rPr>
@@ -6162,7 +6432,7 @@
       </p:sp>
       <p:sp>
         <p:nvSpPr>
-          <p:cNvPr id="14" name="Rectangle 13"/>
+          <p:cNvPr id="20" name="Rectangle 19"/>
           <p:cNvSpPr/>
           <p:nvPr/>
         </p:nvSpPr>
@@ -6175,11 +6445,11 @@
             <a:avLst/>
           </a:prstGeom>
           <a:solidFill>
-            <a:srgbClr val="FBF8F1"/>
+            <a:srgbClr val="FCFBF7"/>
           </a:solidFill>
           <a:ln w="9525">
             <a:solidFill>
-              <a:srgbClr val="C5C2B6"/>
+              <a:srgbClr val="D2CCBF"/>
             </a:solidFill>
           </a:ln>
           <a:effectLst/>
@@ -6194,7 +6464,7 @@
       </p:sp>
       <p:sp>
         <p:nvSpPr>
-          <p:cNvPr id="15" name="Rectangle 14"/>
+          <p:cNvPr id="21" name="Rectangle 20"/>
           <p:cNvSpPr/>
           <p:nvPr/>
         </p:nvSpPr>
@@ -6207,7 +6477,7 @@
             <a:avLst/>
           </a:prstGeom>
           <a:solidFill>
-            <a:srgbClr val="CDD4CE"/>
+            <a:srgbClr val="E4DFD5"/>
           </a:solidFill>
           <a:ln>
             <a:noFill/>
@@ -6224,7 +6494,97 @@
       </p:sp>
       <p:sp>
         <p:nvSpPr>
-          <p:cNvPr id="16" name="TextBox 15"/>
+          <p:cNvPr id="22" name="Rectangle 21"/>
+          <p:cNvSpPr/>
+          <p:nvPr/>
+        </p:nvSpPr>
+        <p:spPr>
+          <a:xfrm>
+            <a:off x="7092569" y="3608705"/>
+            <a:ext cx="692912" cy="472440"/>
+          </a:xfrm>
+          <a:prstGeom prst="rect">
+            <a:avLst/>
+          </a:prstGeom>
+          <a:noFill/>
+          <a:ln w="12382">
+            <a:solidFill>
+              <a:srgbClr val="9C978C"/>
+            </a:solidFill>
+          </a:ln>
+          <a:effectLst/>
+        </p:spPr>
+        <p:txBody>
+          <a:bodyPr rtlCol="0" anchor="ctr"/>
+          <a:lstStyle/>
+          <a:p>
+            <a:pPr algn="ctr"/>
+          </a:p>
+        </p:txBody>
+      </p:sp>
+      <p:sp>
+        <p:nvSpPr>
+          <p:cNvPr id="23" name="Oval 22"/>
+          <p:cNvSpPr/>
+          <p:nvPr/>
+        </p:nvSpPr>
+        <p:spPr>
+          <a:xfrm>
+            <a:off x="7278395" y="3707917"/>
+            <a:ext cx="321259" cy="321259"/>
+          </a:xfrm>
+          <a:prstGeom prst="ellipse">
+            <a:avLst/>
+          </a:prstGeom>
+          <a:noFill/>
+          <a:ln w="12382">
+            <a:solidFill>
+              <a:srgbClr val="9C978C"/>
+            </a:solidFill>
+          </a:ln>
+          <a:effectLst/>
+        </p:spPr>
+        <p:txBody>
+          <a:bodyPr rtlCol="0" anchor="ctr"/>
+          <a:lstStyle/>
+          <a:p>
+            <a:pPr algn="ctr"/>
+          </a:p>
+        </p:txBody>
+      </p:sp>
+      <p:sp>
+        <p:nvSpPr>
+          <p:cNvPr id="24" name="Rectangle 23"/>
+          <p:cNvSpPr/>
+          <p:nvPr/>
+        </p:nvSpPr>
+        <p:spPr>
+          <a:xfrm>
+            <a:off x="7335088" y="3537839"/>
+            <a:ext cx="207873" cy="70866"/>
+          </a:xfrm>
+          <a:prstGeom prst="rect">
+            <a:avLst/>
+          </a:prstGeom>
+          <a:noFill/>
+          <a:ln w="12382">
+            <a:solidFill>
+              <a:srgbClr val="9C978C"/>
+            </a:solidFill>
+          </a:ln>
+          <a:effectLst/>
+        </p:spPr>
+        <p:txBody>
+          <a:bodyPr rtlCol="0" anchor="ctr"/>
+          <a:lstStyle/>
+          <a:p>
+            <a:pPr algn="ctr"/>
+          </a:p>
+        </p:txBody>
+      </p:sp>
+      <p:sp>
+        <p:nvSpPr>
+          <p:cNvPr id="25" name="TextBox 24"/>
           <p:cNvSpPr txBox="1"/>
           <p:nvPr/>
         </p:nvSpPr>
@@ -6250,9 +6610,9 @@
               </a:lnSpc>
             </a:pPr>
             <a:r>
-              <a:rPr sz="900" b="0">
-                <a:solidFill>
-                  <a:srgbClr val="5A5A55"/>
+              <a:rPr sz="900" b="0" i="0">
+                <a:solidFill>
+                  <a:srgbClr val="6E6A62"/>
                 </a:solidFill>
                 <a:latin typeface="Inter"/>
               </a:rPr>
@@ -6263,7 +6623,7 @@
       </p:sp>
       <p:sp>
         <p:nvSpPr>
-          <p:cNvPr id="17" name="Rectangle 16"/>
+          <p:cNvPr id="26" name="Rectangle 25"/>
           <p:cNvSpPr/>
           <p:nvPr/>
         </p:nvSpPr>
@@ -6276,11 +6636,11 @@
             <a:avLst/>
           </a:prstGeom>
           <a:solidFill>
-            <a:srgbClr val="FBF8F1"/>
+            <a:srgbClr val="FCFBF7"/>
           </a:solidFill>
           <a:ln w="9525">
             <a:solidFill>
-              <a:srgbClr val="C5C2B6"/>
+              <a:srgbClr val="D2CCBF"/>
             </a:solidFill>
           </a:ln>
           <a:effectLst/>
@@ -6295,7 +6655,7 @@
       </p:sp>
       <p:sp>
         <p:nvSpPr>
-          <p:cNvPr id="18" name="Rectangle 17"/>
+          <p:cNvPr id="27" name="Rectangle 26"/>
           <p:cNvSpPr/>
           <p:nvPr/>
         </p:nvSpPr>
@@ -6308,7 +6668,7 @@
             <a:avLst/>
           </a:prstGeom>
           <a:solidFill>
-            <a:srgbClr val="CDD4CE"/>
+            <a:srgbClr val="E4DFD5"/>
           </a:solidFill>
           <a:ln>
             <a:noFill/>
@@ -6325,7 +6685,97 @@
       </p:sp>
       <p:sp>
         <p:nvSpPr>
-          <p:cNvPr id="19" name="Rectangle 18"/>
+          <p:cNvPr id="28" name="Rectangle 27"/>
+          <p:cNvSpPr/>
+          <p:nvPr/>
+        </p:nvSpPr>
+        <p:spPr>
+          <a:xfrm>
+            <a:off x="9778618" y="3608705"/>
+            <a:ext cx="692912" cy="472440"/>
+          </a:xfrm>
+          <a:prstGeom prst="rect">
+            <a:avLst/>
+          </a:prstGeom>
+          <a:noFill/>
+          <a:ln w="12382">
+            <a:solidFill>
+              <a:srgbClr val="9C978C"/>
+            </a:solidFill>
+          </a:ln>
+          <a:effectLst/>
+        </p:spPr>
+        <p:txBody>
+          <a:bodyPr rtlCol="0" anchor="ctr"/>
+          <a:lstStyle/>
+          <a:p>
+            <a:pPr algn="ctr"/>
+          </a:p>
+        </p:txBody>
+      </p:sp>
+      <p:sp>
+        <p:nvSpPr>
+          <p:cNvPr id="29" name="Oval 28"/>
+          <p:cNvSpPr/>
+          <p:nvPr/>
+        </p:nvSpPr>
+        <p:spPr>
+          <a:xfrm>
+            <a:off x="9964445" y="3707917"/>
+            <a:ext cx="321259" cy="321259"/>
+          </a:xfrm>
+          <a:prstGeom prst="ellipse">
+            <a:avLst/>
+          </a:prstGeom>
+          <a:noFill/>
+          <a:ln w="12382">
+            <a:solidFill>
+              <a:srgbClr val="9C978C"/>
+            </a:solidFill>
+          </a:ln>
+          <a:effectLst/>
+        </p:spPr>
+        <p:txBody>
+          <a:bodyPr rtlCol="0" anchor="ctr"/>
+          <a:lstStyle/>
+          <a:p>
+            <a:pPr algn="ctr"/>
+          </a:p>
+        </p:txBody>
+      </p:sp>
+      <p:sp>
+        <p:nvSpPr>
+          <p:cNvPr id="30" name="Rectangle 29"/>
+          <p:cNvSpPr/>
+          <p:nvPr/>
+        </p:nvSpPr>
+        <p:spPr>
+          <a:xfrm>
+            <a:off x="10021138" y="3537839"/>
+            <a:ext cx="207873" cy="70866"/>
+          </a:xfrm>
+          <a:prstGeom prst="rect">
+            <a:avLst/>
+          </a:prstGeom>
+          <a:noFill/>
+          <a:ln w="12382">
+            <a:solidFill>
+              <a:srgbClr val="9C978C"/>
+            </a:solidFill>
+          </a:ln>
+          <a:effectLst/>
+        </p:spPr>
+        <p:txBody>
+          <a:bodyPr rtlCol="0" anchor="ctr"/>
+          <a:lstStyle/>
+          <a:p>
+            <a:pPr algn="ctr"/>
+          </a:p>
+        </p:txBody>
+      </p:sp>
+      <p:sp>
+        <p:nvSpPr>
+          <p:cNvPr id="31" name="Rectangle 30"/>
           <p:cNvSpPr/>
           <p:nvPr/>
         </p:nvSpPr>
@@ -6338,11 +6788,11 @@
             <a:avLst/>
           </a:prstGeom>
           <a:solidFill>
-            <a:srgbClr val="F4F1EA"/>
+            <a:srgbClr val="F7F5F0"/>
           </a:solidFill>
           <a:ln w="9525">
             <a:solidFill>
-              <a:srgbClr val="2B5B5D"/>
+              <a:srgbClr val="1A1714"/>
             </a:solidFill>
           </a:ln>
           <a:effectLst/>
@@ -6357,7 +6807,7 @@
       </p:sp>
       <p:sp>
         <p:nvSpPr>
-          <p:cNvPr id="20" name="TextBox 19"/>
+          <p:cNvPr id="32" name="TextBox 31"/>
           <p:cNvSpPr txBox="1"/>
           <p:nvPr/>
         </p:nvSpPr>
@@ -6383,9 +6833,9 @@
               </a:lnSpc>
             </a:pPr>
             <a:r>
-              <a:rPr sz="750" b="1" spc="60">
-                <a:solidFill>
-                  <a:srgbClr val="2B5B5D"/>
+              <a:rPr sz="750" b="1" i="0" spc="60">
+                <a:solidFill>
+                  <a:srgbClr val="1A1714"/>
                 </a:solidFill>
                 <a:latin typeface="Inter"/>
               </a:rPr>
@@ -6396,7 +6846,7 @@
       </p:sp>
       <p:sp>
         <p:nvSpPr>
-          <p:cNvPr id="21" name="TextBox 20"/>
+          <p:cNvPr id="33" name="TextBox 32"/>
           <p:cNvSpPr txBox="1"/>
           <p:nvPr/>
         </p:nvSpPr>
@@ -6422,9 +6872,9 @@
               </a:lnSpc>
             </a:pPr>
             <a:r>
-              <a:rPr sz="900" b="0">
-                <a:solidFill>
-                  <a:srgbClr val="5A5A55"/>
+              <a:rPr sz="900" b="0" i="0">
+                <a:solidFill>
+                  <a:srgbClr val="6E6A62"/>
                 </a:solidFill>
                 <a:latin typeface="Inter"/>
               </a:rPr>
@@ -6435,7 +6885,7 @@
       </p:sp>
       <p:sp>
         <p:nvSpPr>
-          <p:cNvPr id="22" name="Oval 21"/>
+          <p:cNvPr id="34" name="Oval 33"/>
           <p:cNvSpPr/>
           <p:nvPr/>
         </p:nvSpPr>
@@ -6450,7 +6900,7 @@
           <a:noFill/>
           <a:ln w="14287">
             <a:solidFill>
-              <a:srgbClr val="2B5B5D"/>
+              <a:srgbClr val="1A1714"/>
             </a:solidFill>
           </a:ln>
           <a:effectLst/>
@@ -6465,7 +6915,7 @@
       </p:sp>
       <p:sp>
         <p:nvSpPr>
-          <p:cNvPr id="23" name="TextBox 22"/>
+          <p:cNvPr id="35" name="TextBox 34"/>
           <p:cNvSpPr txBox="1"/>
           <p:nvPr/>
         </p:nvSpPr>
@@ -6491,9 +6941,9 @@
               </a:lnSpc>
             </a:pPr>
             <a:r>
-              <a:rPr sz="1050" b="0">
-                <a:solidFill>
-                  <a:srgbClr val="5A5A55"/>
+              <a:rPr sz="1050" b="0" i="0">
+                <a:solidFill>
+                  <a:srgbClr val="6E6A62"/>
                 </a:solidFill>
                 <a:latin typeface="Inter"/>
               </a:rPr>
@@ -6504,7 +6954,7 @@
       </p:sp>
       <p:sp>
         <p:nvSpPr>
-          <p:cNvPr id="24" name="Rectangle 23"/>
+          <p:cNvPr id="36" name="Rectangle 35"/>
           <p:cNvSpPr/>
           <p:nvPr/>
         </p:nvSpPr>
@@ -6517,7 +6967,7 @@
             <a:avLst/>
           </a:prstGeom>
           <a:solidFill>
-            <a:srgbClr val="D1D1CE"/>
+            <a:srgbClr val="E2DDD3"/>
           </a:solidFill>
           <a:ln>
             <a:noFill/>
@@ -6534,7 +6984,7 @@
       </p:sp>
       <p:pic>
         <p:nvPicPr>
-          <p:cNvPr id="25" name="Picture 24" descr="wordmark-black.png"/>
+          <p:cNvPr id="37" name="Picture 36" descr="wordmark-black.png"/>
           <p:cNvPicPr>
             <a:picLocks noChangeAspect="1"/>
           </p:cNvPicPr>
@@ -6558,7 +7008,7 @@
       </p:pic>
       <p:sp>
         <p:nvSpPr>
-          <p:cNvPr id="26" name="TextBox 25"/>
+          <p:cNvPr id="38" name="TextBox 37"/>
           <p:cNvSpPr txBox="1"/>
           <p:nvPr/>
         </p:nvSpPr>
@@ -6584,20 +7034,20 @@
               </a:lnSpc>
             </a:pPr>
             <a:r>
-              <a:rPr sz="1050" b="1">
-                <a:solidFill>
-                  <a:srgbClr val="2B5B5D"/>
-                </a:solidFill>
-                <a:latin typeface="Jost"/>
+              <a:rPr sz="1050" b="1" i="0">
+                <a:solidFill>
+                  <a:srgbClr val="1A1714"/>
+                </a:solidFill>
+                <a:latin typeface="Fraunces"/>
               </a:rPr>
               <a:t>05</a:t>
             </a:r>
             <a:r>
-              <a:rPr sz="1050" b="1">
-                <a:solidFill>
-                  <a:srgbClr val="5A5A55"/>
-                </a:solidFill>
-                <a:latin typeface="Jost"/>
+              <a:rPr sz="1050" b="1" i="0">
+                <a:solidFill>
+                  <a:srgbClr val="6E6A62"/>
+                </a:solidFill>
+                <a:latin typeface="Fraunces"/>
               </a:rPr>
               <a:t> / 06</a:t>
             </a:r>
@@ -6618,7 +7068,7 @@
     <p:bg>
       <p:bgPr>
         <a:solidFill>
-          <a:srgbClr val="F4F1EA"/>
+          <a:srgbClr val="F7F5F0"/>
         </a:solidFill>
         <a:effectLst/>
       </p:bgPr>
@@ -6645,7 +7095,7 @@
             <a:avLst/>
           </a:prstGeom>
           <a:solidFill>
-            <a:srgbClr val="2B5B5D"/>
+            <a:srgbClr val="1A1714"/>
           </a:solidFill>
           <a:ln>
             <a:noFill/>
@@ -6688,9 +7138,9 @@
               </a:lnSpc>
             </a:pPr>
             <a:r>
-              <a:rPr sz="975" b="1" spc="120">
-                <a:solidFill>
-                  <a:srgbClr val="2B5B5D"/>
+              <a:rPr sz="975" b="1" i="0" spc="120">
+                <a:solidFill>
+                  <a:srgbClr val="1A1714"/>
                 </a:solidFill>
                 <a:latin typeface="Inter"/>
               </a:rPr>
@@ -6727,20 +7177,20 @@
               </a:lnSpc>
             </a:pPr>
             <a:r>
-              <a:rPr sz="4800" b="1" spc="-90">
-                <a:solidFill>
-                  <a:srgbClr val="2D2D2A"/>
-                </a:solidFill>
-                <a:latin typeface="Jost"/>
+              <a:rPr sz="4800" b="1" i="0" spc="-90">
+                <a:solidFill>
+                  <a:srgbClr val="1A1714"/>
+                </a:solidFill>
+                <a:latin typeface="Fraunces"/>
               </a:rPr>
               <a:t>Give me a corner. I'll handle the rest. </a:t>
             </a:r>
             <a:r>
-              <a:rPr sz="4800" b="1" spc="-90">
-                <a:solidFill>
-                  <a:srgbClr val="FF5A36"/>
-                </a:solidFill>
-                <a:latin typeface="Jost"/>
+              <a:rPr sz="4800" b="1" i="0" spc="-90">
+                <a:solidFill>
+                  <a:srgbClr val="1A1714"/>
+                </a:solidFill>
+                <a:latin typeface="Fraunces"/>
               </a:rPr>
               <a:t>→</a:t>
             </a:r>
@@ -6775,9 +7225,9 @@
               </a:lnSpc>
             </a:pPr>
             <a:r>
-              <a:rPr sz="1500" b="0">
-                <a:solidFill>
-                  <a:srgbClr val="5A5A55"/>
+              <a:rPr sz="1500" b="0" i="0">
+                <a:solidFill>
+                  <a:srgbClr val="6E6A62"/>
                 </a:solidFill>
                 <a:latin typeface="Inter"/>
               </a:rPr>
@@ -6814,9 +7264,9 @@
               </a:lnSpc>
             </a:pPr>
             <a:r>
-              <a:rPr sz="1200" b="0">
-                <a:solidFill>
-                  <a:srgbClr val="2D2D2A"/>
+              <a:rPr sz="1200" b="0" i="0">
+                <a:solidFill>
+                  <a:srgbClr val="1A1714"/>
                 </a:solidFill>
                 <a:latin typeface="Inter"/>
               </a:rPr>
@@ -6840,7 +7290,7 @@
             <a:avLst/>
           </a:prstGeom>
           <a:solidFill>
-            <a:srgbClr val="D1D1CE"/>
+            <a:srgbClr val="E2DDD3"/>
           </a:solidFill>
           <a:ln>
             <a:noFill/>
@@ -6883,9 +7333,9 @@
               </a:lnSpc>
             </a:pPr>
             <a:r>
-              <a:rPr sz="1200" b="0">
-                <a:solidFill>
-                  <a:srgbClr val="2D2D2A"/>
+              <a:rPr sz="1200" b="0" i="0">
+                <a:solidFill>
+                  <a:srgbClr val="1A1714"/>
                 </a:solidFill>
                 <a:latin typeface="Inter"/>
               </a:rPr>
@@ -6909,7 +7359,7 @@
             <a:avLst/>
           </a:prstGeom>
           <a:solidFill>
-            <a:srgbClr val="D1D1CE"/>
+            <a:srgbClr val="E2DDD3"/>
           </a:solidFill>
           <a:ln>
             <a:noFill/>
@@ -6952,9 +7402,9 @@
               </a:lnSpc>
             </a:pPr>
             <a:r>
-              <a:rPr sz="1200" b="0">
-                <a:solidFill>
-                  <a:srgbClr val="2D2D2A"/>
+              <a:rPr sz="1200" b="0" i="0">
+                <a:solidFill>
+                  <a:srgbClr val="1A1714"/>
                 </a:solidFill>
                 <a:latin typeface="Inter"/>
               </a:rPr>
@@ -6978,7 +7428,7 @@
             <a:avLst/>
           </a:prstGeom>
           <a:solidFill>
-            <a:srgbClr val="D1D1CE"/>
+            <a:srgbClr val="E2DDD3"/>
           </a:solidFill>
           <a:ln>
             <a:noFill/>
@@ -7045,18 +7495,18 @@
               </a:lnSpc>
             </a:pPr>
             <a:r>
-              <a:rPr sz="1050" b="1">
-                <a:solidFill>
-                  <a:srgbClr val="5A5A55"/>
+              <a:rPr sz="1050" b="1" i="0">
+                <a:solidFill>
+                  <a:srgbClr val="6E6A62"/>
                 </a:solidFill>
                 <a:latin typeface="Inter"/>
               </a:rPr>
               <a:t>I'm Josh Gonzales.</a:t>
             </a:r>
             <a:r>
-              <a:rPr sz="1050" b="0">
-                <a:solidFill>
-                  <a:srgbClr val="5A5A55"/>
+              <a:rPr sz="1050" b="0" i="0">
+                <a:solidFill>
+                  <a:srgbClr val="6E6A62"/>
                 </a:solidFill>
                 <a:latin typeface="Inter"/>
               </a:rPr>
@@ -7080,7 +7530,7 @@
             <a:avLst/>
           </a:prstGeom>
           <a:solidFill>
-            <a:srgbClr val="D1D1CE"/>
+            <a:srgbClr val="E2DDD3"/>
           </a:solidFill>
           <a:ln>
             <a:noFill/>
@@ -7147,20 +7597,20 @@
               </a:lnSpc>
             </a:pPr>
             <a:r>
-              <a:rPr sz="1050" b="1">
-                <a:solidFill>
-                  <a:srgbClr val="2B5B5D"/>
-                </a:solidFill>
-                <a:latin typeface="Jost"/>
+              <a:rPr sz="1050" b="1" i="0">
+                <a:solidFill>
+                  <a:srgbClr val="1A1714"/>
+                </a:solidFill>
+                <a:latin typeface="Fraunces"/>
               </a:rPr>
               <a:t>06</a:t>
             </a:r>
             <a:r>
-              <a:rPr sz="1050" b="1">
-                <a:solidFill>
-                  <a:srgbClr val="5A5A55"/>
-                </a:solidFill>
-                <a:latin typeface="Jost"/>
+              <a:rPr sz="1050" b="1" i="0">
+                <a:solidFill>
+                  <a:srgbClr val="6E6A62"/>
+                </a:solidFill>
+                <a:latin typeface="Fraunces"/>
               </a:rPr>
               <a:t> / 06</a:t>
             </a:r>

</xml_diff>